<commit_message>
chore(kp1-video): keep only the latest take of each audio, cue and brief
The video pipeline emits a new versioned file per take, so audio/ alone
had grown to 235 MB of superseded m4a. Every segment's latest version is
the one the rendered video uses, so the older takes carry no information.
Prunes 56 superseded files (~173 MB) and stops tracking the raw camera
source and QA frame grabs, which live outside git like the mp4s already do.
</commit_message>
<xml_diff>
--- a/10-Knowledge-Products/KP1-GEA/videos/module_1/en/decks/KP1_M1_1.6_Deck_v0.1.pptx
+++ b/10-Knowledge-Products/KP1-GEA/videos/module_1/en/decks/KP1_M1_1.6_Deck_v0.1.pptx
@@ -1433,7 +1433,7 @@
           <a:lstStyle/>
           <a:p>
             <a:r>
-              <a:t>VO: Phase five. Execute and Govern. The question: how do we sustain this? The approved roadmap becomes a project pipeline. The small permanent EA team — two to four senior architects — turns the EA from a one-time delivery into a living repository. The EA Board reviews new projects against the architecture, approves cross-ministry decisions, enforces boundaries between domains. Quarterly reviews. Indefinitely.</a:t>
+              <a:t>VO: Notice the rhythm. Four sign-offs in six months. Your minister does not review every diagram. They review at four moments, each tied to a defined deliverable. Between sign-offs, the architects work. The minister's job in between is to remove obstacles — the political ones, mostly. The technical ones are why the architects were hired.</a:t>
             </a:r>
           </a:p>
         </p:txBody>
@@ -1503,7 +1503,7 @@
           <a:lstStyle/>
           <a:p>
             <a:r>
-              <a:t>VO: Notice the rhythm. Four sign-offs in six months. Your minister does not review every diagram. They review at four moments, each tied to a defined deliverable. Between sign-offs, the architects work. The minister's job in between is to remove obstacles — the political ones, mostly. The technical ones are why the architects were hired.</a:t>
+              <a:t>VO: Phase five. Execute and Govern. The question: how do we sustain this? The approved roadmap becomes a project pipeline. The small permanent EA team — two to four senior architects — turns the EA from a one-time delivery into a living repository. The EA Board reviews new projects against the architecture, approves cross-ministry decisions, enforces boundaries between domains. Quarterly reviews. Indefinitely.</a:t>
             </a:r>
           </a:p>
         </p:txBody>
@@ -16581,29 +16581,27 @@
                 </a:solidFill>
                 <a:latin typeface="Arial"/>
               </a:rPr>
-              <a:t>Phase 5 — Execute &amp; Govern</a:t>
-            </a:r>
-          </a:p>
-        </p:txBody>
-      </p:sp>
-      <p:sp>
-        <p:nvSpPr>
-          <p:cNvPr id="4" name="Rounded Rectangle 3"/>
+              <a:t>Your minister reviews four times — not every diagram</a:t>
+            </a:r>
+          </a:p>
+        </p:txBody>
+      </p:sp>
+      <p:sp>
+        <p:nvSpPr>
+          <p:cNvPr id="4" name="Rectangle 3"/>
           <p:cNvSpPr/>
           <p:nvPr/>
         </p:nvSpPr>
         <p:spPr>
           <a:xfrm>
-            <a:off x="7360920" y="384048"/>
-            <a:ext cx="841248" cy="310896"/>
-          </a:xfrm>
-          <a:prstGeom prst="roundRect">
-            <a:avLst>
-              <a:gd name="adj" fmla="val 35000"/>
-            </a:avLst>
+            <a:off x="822960" y="2514600"/>
+            <a:ext cx="10515600" cy="31750"/>
+          </a:xfrm>
+          <a:prstGeom prst="rect">
+            <a:avLst/>
           </a:prstGeom>
           <a:solidFill>
-            <a:srgbClr val="E5F5FB"/>
+            <a:srgbClr val="BFBFBF"/>
           </a:solidFill>
           <a:ln>
             <a:noFill/>
@@ -16634,22 +16632,20 @@
       </p:sp>
       <p:sp>
         <p:nvSpPr>
-          <p:cNvPr id="5" name="Rounded Rectangle 4"/>
+          <p:cNvPr id="5" name="Diamond 4"/>
           <p:cNvSpPr/>
           <p:nvPr/>
         </p:nvSpPr>
         <p:spPr>
           <a:xfrm>
-            <a:off x="8257032" y="384048"/>
-            <a:ext cx="841248" cy="310896"/>
-          </a:xfrm>
-          <a:prstGeom prst="roundRect">
-            <a:avLst>
-              <a:gd name="adj" fmla="val 35000"/>
-            </a:avLst>
+            <a:off x="1371600" y="2395728"/>
+            <a:ext cx="256032" cy="256032"/>
+          </a:xfrm>
+          <a:prstGeom prst="diamond">
+            <a:avLst/>
           </a:prstGeom>
           <a:solidFill>
-            <a:srgbClr val="E5F5FB"/>
+            <a:srgbClr val="006E96"/>
           </a:solidFill>
           <a:ln>
             <a:noFill/>
@@ -16680,22 +16676,75 @@
       </p:sp>
       <p:sp>
         <p:nvSpPr>
-          <p:cNvPr id="6" name="Rounded Rectangle 5"/>
+          <p:cNvPr id="6" name="TextBox 5"/>
+          <p:cNvSpPr txBox="1"/>
+          <p:nvPr/>
+        </p:nvSpPr>
+        <p:spPr>
+          <a:xfrm>
+            <a:off x="320040" y="2880360"/>
+            <a:ext cx="2377440" cy="1188720"/>
+          </a:xfrm>
+          <a:prstGeom prst="rect">
+            <a:avLst/>
+          </a:prstGeom>
+          <a:noFill/>
+        </p:spPr>
+        <p:txBody>
+          <a:bodyPr wrap="square">
+            <a:spAutoFit/>
+          </a:bodyPr>
+          <a:lstStyle/>
+          <a:p>
+            <a:pPr algn="ctr">
+              <a:spcAft>
+                <a:spcPts val="300"/>
+              </a:spcAft>
+            </a:pPr>
+            <a:r>
+              <a:rPr sz="1400" b="1" i="0">
+                <a:solidFill>
+                  <a:srgbClr val="1A1A1A"/>
+                </a:solidFill>
+                <a:latin typeface="Arial"/>
+              </a:rPr>
+              <a:t>The picture is accurate</a:t>
+            </a:r>
+          </a:p>
+          <a:p>
+            <a:pPr algn="ctr">
+              <a:spcAft>
+                <a:spcPts val="300"/>
+              </a:spcAft>
+            </a:pPr>
+            <a:r>
+              <a:rPr sz="1200" b="0" i="0">
+                <a:solidFill>
+                  <a:srgbClr val="595959"/>
+                </a:solidFill>
+                <a:latin typeface="Arial"/>
+              </a:rPr>
+              <a:t>end of Discover</a:t>
+            </a:r>
+          </a:p>
+        </p:txBody>
+      </p:sp>
+      <p:sp>
+        <p:nvSpPr>
+          <p:cNvPr id="7" name="Diamond 6"/>
           <p:cNvSpPr/>
           <p:nvPr/>
         </p:nvSpPr>
         <p:spPr>
           <a:xfrm>
-            <a:off x="9153144" y="384048"/>
-            <a:ext cx="841248" cy="310896"/>
-          </a:xfrm>
-          <a:prstGeom prst="roundRect">
-            <a:avLst>
-              <a:gd name="adj" fmla="val 35000"/>
-            </a:avLst>
+            <a:off x="4069080" y="2395728"/>
+            <a:ext cx="256032" cy="256032"/>
+          </a:xfrm>
+          <a:prstGeom prst="diamond">
+            <a:avLst/>
           </a:prstGeom>
           <a:solidFill>
-            <a:srgbClr val="E5F5FB"/>
+            <a:srgbClr val="006E96"/>
           </a:solidFill>
           <a:ln>
             <a:noFill/>
@@ -16726,22 +16775,75 @@
       </p:sp>
       <p:sp>
         <p:nvSpPr>
-          <p:cNvPr id="7" name="Rounded Rectangle 6"/>
+          <p:cNvPr id="8" name="TextBox 7"/>
+          <p:cNvSpPr txBox="1"/>
+          <p:nvPr/>
+        </p:nvSpPr>
+        <p:spPr>
+          <a:xfrm>
+            <a:off x="3017520" y="2880360"/>
+            <a:ext cx="2377440" cy="1188720"/>
+          </a:xfrm>
+          <a:prstGeom prst="rect">
+            <a:avLst/>
+          </a:prstGeom>
+          <a:noFill/>
+        </p:spPr>
+        <p:txBody>
+          <a:bodyPr wrap="square">
+            <a:spAutoFit/>
+          </a:bodyPr>
+          <a:lstStyle/>
+          <a:p>
+            <a:pPr algn="ctr">
+              <a:spcAft>
+                <a:spcPts val="300"/>
+              </a:spcAft>
+            </a:pPr>
+            <a:r>
+              <a:rPr sz="1400" b="1" i="0">
+                <a:solidFill>
+                  <a:srgbClr val="1A1A1A"/>
+                </a:solidFill>
+                <a:latin typeface="Arial"/>
+              </a:rPr>
+              <a:t>The gap reflects ground truth</a:t>
+            </a:r>
+          </a:p>
+          <a:p>
+            <a:pPr algn="ctr">
+              <a:spcAft>
+                <a:spcPts val="300"/>
+              </a:spcAft>
+            </a:pPr>
+            <a:r>
+              <a:rPr sz="1200" b="0" i="0">
+                <a:solidFill>
+                  <a:srgbClr val="595959"/>
+                </a:solidFill>
+                <a:latin typeface="Arial"/>
+              </a:rPr>
+              <a:t>end of Assess</a:t>
+            </a:r>
+          </a:p>
+        </p:txBody>
+      </p:sp>
+      <p:sp>
+        <p:nvSpPr>
+          <p:cNvPr id="9" name="Diamond 8"/>
           <p:cNvSpPr/>
           <p:nvPr/>
         </p:nvSpPr>
         <p:spPr>
           <a:xfrm>
-            <a:off x="10049256" y="384048"/>
-            <a:ext cx="841248" cy="310896"/>
-          </a:xfrm>
-          <a:prstGeom prst="roundRect">
-            <a:avLst>
-              <a:gd name="adj" fmla="val 35000"/>
-            </a:avLst>
+            <a:off x="6766560" y="2395728"/>
+            <a:ext cx="256032" cy="256032"/>
+          </a:xfrm>
+          <a:prstGeom prst="diamond">
+            <a:avLst/>
           </a:prstGeom>
           <a:solidFill>
-            <a:srgbClr val="E5F5FB"/>
+            <a:srgbClr val="006E96"/>
           </a:solidFill>
           <a:ln>
             <a:noFill/>
@@ -16772,22 +16874,75 @@
       </p:sp>
       <p:sp>
         <p:nvSpPr>
-          <p:cNvPr id="8" name="Rounded Rectangle 7"/>
+          <p:cNvPr id="10" name="TextBox 9"/>
+          <p:cNvSpPr txBox="1"/>
+          <p:nvPr/>
+        </p:nvSpPr>
+        <p:spPr>
+          <a:xfrm>
+            <a:off x="5715000" y="2880360"/>
+            <a:ext cx="2377440" cy="1188720"/>
+          </a:xfrm>
+          <a:prstGeom prst="rect">
+            <a:avLst/>
+          </a:prstGeom>
+          <a:noFill/>
+        </p:spPr>
+        <p:txBody>
+          <a:bodyPr wrap="square">
+            <a:spAutoFit/>
+          </a:bodyPr>
+          <a:lstStyle/>
+          <a:p>
+            <a:pPr algn="ctr">
+              <a:spcAft>
+                <a:spcPts val="300"/>
+              </a:spcAft>
+            </a:pPr>
+            <a:r>
+              <a:rPr sz="1400" b="1" i="0">
+                <a:solidFill>
+                  <a:srgbClr val="1A1A1A"/>
+                </a:solidFill>
+                <a:latin typeface="Arial"/>
+              </a:rPr>
+              <a:t>Framework + sourcing approach</a:t>
+            </a:r>
+          </a:p>
+          <a:p>
+            <a:pPr algn="ctr">
+              <a:spcAft>
+                <a:spcPts val="300"/>
+              </a:spcAft>
+            </a:pPr>
+            <a:r>
+              <a:rPr sz="1200" b="0" i="0">
+                <a:solidFill>
+                  <a:srgbClr val="595959"/>
+                </a:solidFill>
+                <a:latin typeface="Arial"/>
+              </a:rPr>
+              <a:t>end of Adapt</a:t>
+            </a:r>
+          </a:p>
+        </p:txBody>
+      </p:sp>
+      <p:sp>
+        <p:nvSpPr>
+          <p:cNvPr id="11" name="Diamond 10"/>
           <p:cNvSpPr/>
           <p:nvPr/>
         </p:nvSpPr>
         <p:spPr>
           <a:xfrm>
-            <a:off x="10945368" y="384048"/>
-            <a:ext cx="841248" cy="310896"/>
-          </a:xfrm>
-          <a:prstGeom prst="roundRect">
-            <a:avLst>
-              <a:gd name="adj" fmla="val 35000"/>
-            </a:avLst>
+            <a:off x="9464040" y="2395728"/>
+            <a:ext cx="256032" cy="256032"/>
+          </a:xfrm>
+          <a:prstGeom prst="diamond">
+            <a:avLst/>
           </a:prstGeom>
           <a:solidFill>
-            <a:srgbClr val="009CD6"/>
+            <a:srgbClr val="006E96"/>
           </a:solidFill>
           <a:ln>
             <a:noFill/>
@@ -16818,14 +16973,14 @@
       </p:sp>
       <p:sp>
         <p:nvSpPr>
-          <p:cNvPr id="9" name="TextBox 8"/>
+          <p:cNvPr id="12" name="TextBox 11"/>
           <p:cNvSpPr txBox="1"/>
           <p:nvPr/>
         </p:nvSpPr>
         <p:spPr>
           <a:xfrm>
-            <a:off x="658368" y="1508760"/>
-            <a:ext cx="2103120" cy="548640"/>
+            <a:off x="8412480" y="2880360"/>
+            <a:ext cx="2377440" cy="1188720"/>
           </a:xfrm>
           <a:prstGeom prst="rect">
             <a:avLst/>
@@ -16838,28 +16993,49 @@
           </a:bodyPr>
           <a:lstStyle/>
           <a:p>
-            <a:r>
-              <a:rPr sz="1300" b="1" i="0">
+            <a:pPr algn="ctr">
+              <a:spcAft>
+                <a:spcPts val="300"/>
+              </a:spcAft>
+            </a:pPr>
+            <a:r>
+              <a:rPr sz="1400" b="1" i="0">
                 <a:solidFill>
-                  <a:srgbClr val="006E96"/>
+                  <a:srgbClr val="1A1A1A"/>
                 </a:solidFill>
                 <a:latin typeface="Arial"/>
               </a:rPr>
-              <a:t>QUESTION</a:t>
-            </a:r>
-          </a:p>
-        </p:txBody>
-      </p:sp>
-      <p:sp>
-        <p:nvSpPr>
-          <p:cNvPr id="10" name="TextBox 9"/>
+              <a:t>Roadmap approved, budget committed</a:t>
+            </a:r>
+          </a:p>
+          <a:p>
+            <a:pPr algn="ctr">
+              <a:spcAft>
+                <a:spcPts val="300"/>
+              </a:spcAft>
+            </a:pPr>
+            <a:r>
+              <a:rPr sz="1200" b="0" i="0">
+                <a:solidFill>
+                  <a:srgbClr val="595959"/>
+                </a:solidFill>
+                <a:latin typeface="Arial"/>
+              </a:rPr>
+              <a:t>end of Plan</a:t>
+            </a:r>
+          </a:p>
+        </p:txBody>
+      </p:sp>
+      <p:sp>
+        <p:nvSpPr>
+          <p:cNvPr id="13" name="TextBox 12"/>
           <p:cNvSpPr txBox="1"/>
           <p:nvPr/>
         </p:nvSpPr>
         <p:spPr>
           <a:xfrm>
-            <a:off x="2834640" y="1490472"/>
-            <a:ext cx="8595360" cy="914400"/>
+            <a:off x="822960" y="4480560"/>
+            <a:ext cx="10515600" cy="1463040"/>
           </a:xfrm>
           <a:prstGeom prst="rect">
             <a:avLst/>
@@ -16872,6 +17048,11 @@
           </a:bodyPr>
           <a:lstStyle/>
           <a:p>
+            <a:pPr>
+              <a:spcAft>
+                <a:spcPts val="800"/>
+              </a:spcAft>
+            </a:pPr>
             <a:r>
               <a:rPr sz="1800" b="0" i="0">
                 <a:solidFill>
@@ -16879,109 +17060,23 @@
                 </a:solidFill>
                 <a:latin typeface="Arial"/>
               </a:rPr>
-              <a:t>How do we sustain this?</a:t>
-            </a:r>
-          </a:p>
-        </p:txBody>
-      </p:sp>
-      <p:sp>
-        <p:nvSpPr>
-          <p:cNvPr id="11" name="TextBox 10"/>
-          <p:cNvSpPr txBox="1"/>
-          <p:nvPr/>
-        </p:nvSpPr>
-        <p:spPr>
-          <a:xfrm>
-            <a:off x="658368" y="2587752"/>
-            <a:ext cx="2103120" cy="548640"/>
-          </a:xfrm>
-          <a:prstGeom prst="rect">
-            <a:avLst/>
-          </a:prstGeom>
-          <a:noFill/>
-        </p:spPr>
-        <p:txBody>
-          <a:bodyPr wrap="square">
-            <a:spAutoFit/>
-          </a:bodyPr>
-          <a:lstStyle/>
-          <a:p>
-            <a:r>
-              <a:rPr sz="1300" b="1" i="0">
+              <a:t>Between sign-offs, the architects work.</a:t>
+            </a:r>
+          </a:p>
+          <a:p>
+            <a:pPr>
+              <a:spcAft>
+                <a:spcPts val="800"/>
+              </a:spcAft>
+            </a:pPr>
+            <a:r>
+              <a:rPr sz="1800" b="0" i="0">
                 <a:solidFill>
-                  <a:srgbClr val="006E96"/>
+                  <a:srgbClr val="595959"/>
                 </a:solidFill>
                 <a:latin typeface="Arial"/>
               </a:rPr>
-              <a:t>DELIVERABLE</a:t>
-            </a:r>
-          </a:p>
-        </p:txBody>
-      </p:sp>
-      <p:sp>
-        <p:nvSpPr>
-          <p:cNvPr id="12" name="TextBox 11"/>
-          <p:cNvSpPr txBox="1"/>
-          <p:nvPr/>
-        </p:nvSpPr>
-        <p:spPr>
-          <a:xfrm>
-            <a:off x="2834640" y="2569464"/>
-            <a:ext cx="8595360" cy="1417320"/>
-          </a:xfrm>
-          <a:prstGeom prst="rect">
-            <a:avLst/>
-          </a:prstGeom>
-          <a:noFill/>
-        </p:spPr>
-        <p:txBody>
-          <a:bodyPr wrap="square">
-            <a:spAutoFit/>
-          </a:bodyPr>
-          <a:lstStyle/>
-          <a:p>
-            <a:r>
-              <a:rPr sz="1800" b="1" i="0">
-                <a:solidFill>
-                  <a:srgbClr val="1A1A1A"/>
-                </a:solidFill>
-                <a:latin typeface="Arial"/>
-              </a:rPr>
-              <a:t>A living, governed EA — repository plus practice. The 2–4 permanent architects keep it alive; the EA Board reviews projects against it.</a:t>
-            </a:r>
-          </a:p>
-        </p:txBody>
-      </p:sp>
-      <p:sp>
-        <p:nvSpPr>
-          <p:cNvPr id="13" name="TextBox 12"/>
-          <p:cNvSpPr txBox="1"/>
-          <p:nvPr/>
-        </p:nvSpPr>
-        <p:spPr>
-          <a:xfrm>
-            <a:off x="658368" y="4169664"/>
-            <a:ext cx="2103120" cy="548640"/>
-          </a:xfrm>
-          <a:prstGeom prst="rect">
-            <a:avLst/>
-          </a:prstGeom>
-          <a:noFill/>
-        </p:spPr>
-        <p:txBody>
-          <a:bodyPr wrap="square">
-            <a:spAutoFit/>
-          </a:bodyPr>
-          <a:lstStyle/>
-          <a:p>
-            <a:r>
-              <a:rPr sz="1300" b="1" i="0">
-                <a:solidFill>
-                  <a:srgbClr val="006E96"/>
-                </a:solidFill>
-                <a:latin typeface="Arial"/>
-              </a:rPr>
-              <a:t>CADENCE</a:t>
+              <a:t>The minister’s job in between is to remove obstacles — the political ones, mostly. The technical ones are why the architects were hired.</a:t>
             </a:r>
           </a:p>
         </p:txBody>
@@ -16989,108 +17084,6 @@
       <p:sp>
         <p:nvSpPr>
           <p:cNvPr id="14" name="TextBox 13"/>
-          <p:cNvSpPr txBox="1"/>
-          <p:nvPr/>
-        </p:nvSpPr>
-        <p:spPr>
-          <a:xfrm>
-            <a:off x="2834640" y="4151376"/>
-            <a:ext cx="8595360" cy="1325880"/>
-          </a:xfrm>
-          <a:prstGeom prst="rect">
-            <a:avLst/>
-          </a:prstGeom>
-          <a:noFill/>
-        </p:spPr>
-        <p:txBody>
-          <a:bodyPr wrap="square">
-            <a:spAutoFit/>
-          </a:bodyPr>
-          <a:lstStyle/>
-          <a:p>
-            <a:r>
-              <a:rPr sz="1800" b="1" i="0">
-                <a:solidFill>
-                  <a:srgbClr val="1A1A1A"/>
-                </a:solidFill>
-                <a:latin typeface="Arial"/>
-              </a:rPr>
-              <a:t>Quarterly Board reviews — indefinitely. New projects reviewed against the architecture; cross-ministry decisions approved; domain boundaries enforced.</a:t>
-            </a:r>
-          </a:p>
-        </p:txBody>
-      </p:sp>
-      <p:sp>
-        <p:nvSpPr>
-          <p:cNvPr id="15" name="TextBox 14"/>
-          <p:cNvSpPr txBox="1"/>
-          <p:nvPr/>
-        </p:nvSpPr>
-        <p:spPr>
-          <a:xfrm>
-            <a:off x="658368" y="5660136"/>
-            <a:ext cx="2103120" cy="548640"/>
-          </a:xfrm>
-          <a:prstGeom prst="rect">
-            <a:avLst/>
-          </a:prstGeom>
-          <a:noFill/>
-        </p:spPr>
-        <p:txBody>
-          <a:bodyPr wrap="square">
-            <a:spAutoFit/>
-          </a:bodyPr>
-          <a:lstStyle/>
-          <a:p>
-            <a:r>
-              <a:rPr sz="1300" b="1" i="0">
-                <a:solidFill>
-                  <a:srgbClr val="006E96"/>
-                </a:solidFill>
-                <a:latin typeface="Arial"/>
-              </a:rPr>
-              <a:t>DURATION</a:t>
-            </a:r>
-          </a:p>
-        </p:txBody>
-      </p:sp>
-      <p:sp>
-        <p:nvSpPr>
-          <p:cNvPr id="16" name="TextBox 15"/>
-          <p:cNvSpPr txBox="1"/>
-          <p:nvPr/>
-        </p:nvSpPr>
-        <p:spPr>
-          <a:xfrm>
-            <a:off x="2834640" y="5641848"/>
-            <a:ext cx="8595360" cy="777240"/>
-          </a:xfrm>
-          <a:prstGeom prst="rect">
-            <a:avLst/>
-          </a:prstGeom>
-          <a:noFill/>
-        </p:spPr>
-        <p:txBody>
-          <a:bodyPr wrap="square">
-            <a:spAutoFit/>
-          </a:bodyPr>
-          <a:lstStyle/>
-          <a:p>
-            <a:r>
-              <a:rPr sz="1800" b="0" i="0">
-                <a:solidFill>
-                  <a:srgbClr val="1A1A1A"/>
-                </a:solidFill>
-                <a:latin typeface="Arial"/>
-              </a:rPr>
-              <a:t>Ongoing — your country’s permanent way of working</a:t>
-            </a:r>
-          </a:p>
-        </p:txBody>
-      </p:sp>
-      <p:sp>
-        <p:nvSpPr>
-          <p:cNvPr id="17" name="TextBox 16"/>
           <p:cNvSpPr txBox="1"/>
           <p:nvPr/>
         </p:nvSpPr>
@@ -17213,27 +17206,29 @@
                 </a:solidFill>
                 <a:latin typeface="Arial"/>
               </a:rPr>
-              <a:t>Your minister reviews four times — not every diagram</a:t>
-            </a:r>
-          </a:p>
-        </p:txBody>
-      </p:sp>
-      <p:sp>
-        <p:nvSpPr>
-          <p:cNvPr id="4" name="Rectangle 3"/>
+              <a:t>Phase 5 — Execute &amp; Govern</a:t>
+            </a:r>
+          </a:p>
+        </p:txBody>
+      </p:sp>
+      <p:sp>
+        <p:nvSpPr>
+          <p:cNvPr id="4" name="Rounded Rectangle 3"/>
           <p:cNvSpPr/>
           <p:nvPr/>
         </p:nvSpPr>
         <p:spPr>
           <a:xfrm>
-            <a:off x="822960" y="2514600"/>
-            <a:ext cx="10515600" cy="31750"/>
-          </a:xfrm>
-          <a:prstGeom prst="rect">
-            <a:avLst/>
+            <a:off x="7360920" y="384048"/>
+            <a:ext cx="841248" cy="310896"/>
+          </a:xfrm>
+          <a:prstGeom prst="roundRect">
+            <a:avLst>
+              <a:gd name="adj" fmla="val 35000"/>
+            </a:avLst>
           </a:prstGeom>
           <a:solidFill>
-            <a:srgbClr val="BFBFBF"/>
+            <a:srgbClr val="E5F5FB"/>
           </a:solidFill>
           <a:ln>
             <a:noFill/>
@@ -17264,20 +17259,22 @@
       </p:sp>
       <p:sp>
         <p:nvSpPr>
-          <p:cNvPr id="5" name="Diamond 4"/>
+          <p:cNvPr id="5" name="Rounded Rectangle 4"/>
           <p:cNvSpPr/>
           <p:nvPr/>
         </p:nvSpPr>
         <p:spPr>
           <a:xfrm>
-            <a:off x="1371600" y="2395728"/>
-            <a:ext cx="256032" cy="256032"/>
-          </a:xfrm>
-          <a:prstGeom prst="diamond">
-            <a:avLst/>
+            <a:off x="8257032" y="384048"/>
+            <a:ext cx="841248" cy="310896"/>
+          </a:xfrm>
+          <a:prstGeom prst="roundRect">
+            <a:avLst>
+              <a:gd name="adj" fmla="val 35000"/>
+            </a:avLst>
           </a:prstGeom>
           <a:solidFill>
-            <a:srgbClr val="006E96"/>
+            <a:srgbClr val="E5F5FB"/>
           </a:solidFill>
           <a:ln>
             <a:noFill/>
@@ -17308,75 +17305,22 @@
       </p:sp>
       <p:sp>
         <p:nvSpPr>
-          <p:cNvPr id="6" name="TextBox 5"/>
-          <p:cNvSpPr txBox="1"/>
-          <p:nvPr/>
-        </p:nvSpPr>
-        <p:spPr>
-          <a:xfrm>
-            <a:off x="320040" y="2880360"/>
-            <a:ext cx="2377440" cy="1188720"/>
-          </a:xfrm>
-          <a:prstGeom prst="rect">
-            <a:avLst/>
-          </a:prstGeom>
-          <a:noFill/>
-        </p:spPr>
-        <p:txBody>
-          <a:bodyPr wrap="square">
-            <a:spAutoFit/>
-          </a:bodyPr>
-          <a:lstStyle/>
-          <a:p>
-            <a:pPr algn="ctr">
-              <a:spcAft>
-                <a:spcPts val="300"/>
-              </a:spcAft>
-            </a:pPr>
-            <a:r>
-              <a:rPr sz="1400" b="1" i="0">
-                <a:solidFill>
-                  <a:srgbClr val="1A1A1A"/>
-                </a:solidFill>
-                <a:latin typeface="Arial"/>
-              </a:rPr>
-              <a:t>The picture is accurate</a:t>
-            </a:r>
-          </a:p>
-          <a:p>
-            <a:pPr algn="ctr">
-              <a:spcAft>
-                <a:spcPts val="300"/>
-              </a:spcAft>
-            </a:pPr>
-            <a:r>
-              <a:rPr sz="1200" b="0" i="0">
-                <a:solidFill>
-                  <a:srgbClr val="595959"/>
-                </a:solidFill>
-                <a:latin typeface="Arial"/>
-              </a:rPr>
-              <a:t>end of Discover</a:t>
-            </a:r>
-          </a:p>
-        </p:txBody>
-      </p:sp>
-      <p:sp>
-        <p:nvSpPr>
-          <p:cNvPr id="7" name="Diamond 6"/>
+          <p:cNvPr id="6" name="Rounded Rectangle 5"/>
           <p:cNvSpPr/>
           <p:nvPr/>
         </p:nvSpPr>
         <p:spPr>
           <a:xfrm>
-            <a:off x="4069080" y="2395728"/>
-            <a:ext cx="256032" cy="256032"/>
-          </a:xfrm>
-          <a:prstGeom prst="diamond">
-            <a:avLst/>
+            <a:off x="9153144" y="384048"/>
+            <a:ext cx="841248" cy="310896"/>
+          </a:xfrm>
+          <a:prstGeom prst="roundRect">
+            <a:avLst>
+              <a:gd name="adj" fmla="val 35000"/>
+            </a:avLst>
           </a:prstGeom>
           <a:solidFill>
-            <a:srgbClr val="006E96"/>
+            <a:srgbClr val="E5F5FB"/>
           </a:solidFill>
           <a:ln>
             <a:noFill/>
@@ -17407,75 +17351,22 @@
       </p:sp>
       <p:sp>
         <p:nvSpPr>
-          <p:cNvPr id="8" name="TextBox 7"/>
-          <p:cNvSpPr txBox="1"/>
-          <p:nvPr/>
-        </p:nvSpPr>
-        <p:spPr>
-          <a:xfrm>
-            <a:off x="3017520" y="2880360"/>
-            <a:ext cx="2377440" cy="1188720"/>
-          </a:xfrm>
-          <a:prstGeom prst="rect">
-            <a:avLst/>
-          </a:prstGeom>
-          <a:noFill/>
-        </p:spPr>
-        <p:txBody>
-          <a:bodyPr wrap="square">
-            <a:spAutoFit/>
-          </a:bodyPr>
-          <a:lstStyle/>
-          <a:p>
-            <a:pPr algn="ctr">
-              <a:spcAft>
-                <a:spcPts val="300"/>
-              </a:spcAft>
-            </a:pPr>
-            <a:r>
-              <a:rPr sz="1400" b="1" i="0">
-                <a:solidFill>
-                  <a:srgbClr val="1A1A1A"/>
-                </a:solidFill>
-                <a:latin typeface="Arial"/>
-              </a:rPr>
-              <a:t>The gap reflects ground truth</a:t>
-            </a:r>
-          </a:p>
-          <a:p>
-            <a:pPr algn="ctr">
-              <a:spcAft>
-                <a:spcPts val="300"/>
-              </a:spcAft>
-            </a:pPr>
-            <a:r>
-              <a:rPr sz="1200" b="0" i="0">
-                <a:solidFill>
-                  <a:srgbClr val="595959"/>
-                </a:solidFill>
-                <a:latin typeface="Arial"/>
-              </a:rPr>
-              <a:t>end of Assess</a:t>
-            </a:r>
-          </a:p>
-        </p:txBody>
-      </p:sp>
-      <p:sp>
-        <p:nvSpPr>
-          <p:cNvPr id="9" name="Diamond 8"/>
+          <p:cNvPr id="7" name="Rounded Rectangle 6"/>
           <p:cNvSpPr/>
           <p:nvPr/>
         </p:nvSpPr>
         <p:spPr>
           <a:xfrm>
-            <a:off x="6766560" y="2395728"/>
-            <a:ext cx="256032" cy="256032"/>
-          </a:xfrm>
-          <a:prstGeom prst="diamond">
-            <a:avLst/>
+            <a:off x="10049256" y="384048"/>
+            <a:ext cx="841248" cy="310896"/>
+          </a:xfrm>
+          <a:prstGeom prst="roundRect">
+            <a:avLst>
+              <a:gd name="adj" fmla="val 35000"/>
+            </a:avLst>
           </a:prstGeom>
           <a:solidFill>
-            <a:srgbClr val="006E96"/>
+            <a:srgbClr val="E5F5FB"/>
           </a:solidFill>
           <a:ln>
             <a:noFill/>
@@ -17506,75 +17397,22 @@
       </p:sp>
       <p:sp>
         <p:nvSpPr>
-          <p:cNvPr id="10" name="TextBox 9"/>
-          <p:cNvSpPr txBox="1"/>
-          <p:nvPr/>
-        </p:nvSpPr>
-        <p:spPr>
-          <a:xfrm>
-            <a:off x="5715000" y="2880360"/>
-            <a:ext cx="2377440" cy="1188720"/>
-          </a:xfrm>
-          <a:prstGeom prst="rect">
-            <a:avLst/>
-          </a:prstGeom>
-          <a:noFill/>
-        </p:spPr>
-        <p:txBody>
-          <a:bodyPr wrap="square">
-            <a:spAutoFit/>
-          </a:bodyPr>
-          <a:lstStyle/>
-          <a:p>
-            <a:pPr algn="ctr">
-              <a:spcAft>
-                <a:spcPts val="300"/>
-              </a:spcAft>
-            </a:pPr>
-            <a:r>
-              <a:rPr sz="1400" b="1" i="0">
-                <a:solidFill>
-                  <a:srgbClr val="1A1A1A"/>
-                </a:solidFill>
-                <a:latin typeface="Arial"/>
-              </a:rPr>
-              <a:t>Framework + sourcing approach</a:t>
-            </a:r>
-          </a:p>
-          <a:p>
-            <a:pPr algn="ctr">
-              <a:spcAft>
-                <a:spcPts val="300"/>
-              </a:spcAft>
-            </a:pPr>
-            <a:r>
-              <a:rPr sz="1200" b="0" i="0">
-                <a:solidFill>
-                  <a:srgbClr val="595959"/>
-                </a:solidFill>
-                <a:latin typeface="Arial"/>
-              </a:rPr>
-              <a:t>end of Adapt</a:t>
-            </a:r>
-          </a:p>
-        </p:txBody>
-      </p:sp>
-      <p:sp>
-        <p:nvSpPr>
-          <p:cNvPr id="11" name="Diamond 10"/>
+          <p:cNvPr id="8" name="Rounded Rectangle 7"/>
           <p:cNvSpPr/>
           <p:nvPr/>
         </p:nvSpPr>
         <p:spPr>
           <a:xfrm>
-            <a:off x="9464040" y="2395728"/>
-            <a:ext cx="256032" cy="256032"/>
-          </a:xfrm>
-          <a:prstGeom prst="diamond">
-            <a:avLst/>
+            <a:off x="10945368" y="384048"/>
+            <a:ext cx="841248" cy="310896"/>
+          </a:xfrm>
+          <a:prstGeom prst="roundRect">
+            <a:avLst>
+              <a:gd name="adj" fmla="val 35000"/>
+            </a:avLst>
           </a:prstGeom>
           <a:solidFill>
-            <a:srgbClr val="006E96"/>
+            <a:srgbClr val="009CD6"/>
           </a:solidFill>
           <a:ln>
             <a:noFill/>
@@ -17605,14 +17443,14 @@
       </p:sp>
       <p:sp>
         <p:nvSpPr>
-          <p:cNvPr id="12" name="TextBox 11"/>
+          <p:cNvPr id="9" name="TextBox 8"/>
           <p:cNvSpPr txBox="1"/>
           <p:nvPr/>
         </p:nvSpPr>
         <p:spPr>
           <a:xfrm>
-            <a:off x="8412480" y="2880360"/>
-            <a:ext cx="2377440" cy="1188720"/>
+            <a:off x="658368" y="1508760"/>
+            <a:ext cx="2103120" cy="548640"/>
           </a:xfrm>
           <a:prstGeom prst="rect">
             <a:avLst/>
@@ -17625,49 +17463,28 @@
           </a:bodyPr>
           <a:lstStyle/>
           <a:p>
-            <a:pPr algn="ctr">
-              <a:spcAft>
-                <a:spcPts val="300"/>
-              </a:spcAft>
-            </a:pPr>
-            <a:r>
-              <a:rPr sz="1400" b="1" i="0">
+            <a:r>
+              <a:rPr sz="1300" b="1" i="0">
                 <a:solidFill>
-                  <a:srgbClr val="1A1A1A"/>
+                  <a:srgbClr val="006E96"/>
                 </a:solidFill>
                 <a:latin typeface="Arial"/>
               </a:rPr>
-              <a:t>Roadmap approved, budget committed</a:t>
-            </a:r>
-          </a:p>
-          <a:p>
-            <a:pPr algn="ctr">
-              <a:spcAft>
-                <a:spcPts val="300"/>
-              </a:spcAft>
-            </a:pPr>
-            <a:r>
-              <a:rPr sz="1200" b="0" i="0">
-                <a:solidFill>
-                  <a:srgbClr val="595959"/>
-                </a:solidFill>
-                <a:latin typeface="Arial"/>
-              </a:rPr>
-              <a:t>end of Plan</a:t>
-            </a:r>
-          </a:p>
-        </p:txBody>
-      </p:sp>
-      <p:sp>
-        <p:nvSpPr>
-          <p:cNvPr id="13" name="TextBox 12"/>
+              <a:t>QUESTION</a:t>
+            </a:r>
+          </a:p>
+        </p:txBody>
+      </p:sp>
+      <p:sp>
+        <p:nvSpPr>
+          <p:cNvPr id="10" name="TextBox 9"/>
           <p:cNvSpPr txBox="1"/>
           <p:nvPr/>
         </p:nvSpPr>
         <p:spPr>
           <a:xfrm>
-            <a:off x="822960" y="4480560"/>
-            <a:ext cx="10515600" cy="1463040"/>
+            <a:off x="2834640" y="1490472"/>
+            <a:ext cx="8595360" cy="914400"/>
           </a:xfrm>
           <a:prstGeom prst="rect">
             <a:avLst/>
@@ -17680,11 +17497,6 @@
           </a:bodyPr>
           <a:lstStyle/>
           <a:p>
-            <a:pPr>
-              <a:spcAft>
-                <a:spcPts val="800"/>
-              </a:spcAft>
-            </a:pPr>
             <a:r>
               <a:rPr sz="1800" b="0" i="0">
                 <a:solidFill>
@@ -17692,23 +17504,109 @@
                 </a:solidFill>
                 <a:latin typeface="Arial"/>
               </a:rPr>
-              <a:t>Between sign-offs, the architects work.</a:t>
-            </a:r>
-          </a:p>
-          <a:p>
-            <a:pPr>
-              <a:spcAft>
-                <a:spcPts val="800"/>
-              </a:spcAft>
-            </a:pPr>
-            <a:r>
-              <a:rPr sz="1800" b="0" i="0">
+              <a:t>How do we sustain this?</a:t>
+            </a:r>
+          </a:p>
+        </p:txBody>
+      </p:sp>
+      <p:sp>
+        <p:nvSpPr>
+          <p:cNvPr id="11" name="TextBox 10"/>
+          <p:cNvSpPr txBox="1"/>
+          <p:nvPr/>
+        </p:nvSpPr>
+        <p:spPr>
+          <a:xfrm>
+            <a:off x="658368" y="2587752"/>
+            <a:ext cx="2103120" cy="548640"/>
+          </a:xfrm>
+          <a:prstGeom prst="rect">
+            <a:avLst/>
+          </a:prstGeom>
+          <a:noFill/>
+        </p:spPr>
+        <p:txBody>
+          <a:bodyPr wrap="square">
+            <a:spAutoFit/>
+          </a:bodyPr>
+          <a:lstStyle/>
+          <a:p>
+            <a:r>
+              <a:rPr sz="1300" b="1" i="0">
                 <a:solidFill>
-                  <a:srgbClr val="595959"/>
+                  <a:srgbClr val="006E96"/>
                 </a:solidFill>
                 <a:latin typeface="Arial"/>
               </a:rPr>
-              <a:t>The minister’s job in between is to remove obstacles — the political ones, mostly. The technical ones are why the architects were hired.</a:t>
+              <a:t>DELIVERABLE</a:t>
+            </a:r>
+          </a:p>
+        </p:txBody>
+      </p:sp>
+      <p:sp>
+        <p:nvSpPr>
+          <p:cNvPr id="12" name="TextBox 11"/>
+          <p:cNvSpPr txBox="1"/>
+          <p:nvPr/>
+        </p:nvSpPr>
+        <p:spPr>
+          <a:xfrm>
+            <a:off x="2834640" y="2569464"/>
+            <a:ext cx="8595360" cy="1417320"/>
+          </a:xfrm>
+          <a:prstGeom prst="rect">
+            <a:avLst/>
+          </a:prstGeom>
+          <a:noFill/>
+        </p:spPr>
+        <p:txBody>
+          <a:bodyPr wrap="square">
+            <a:spAutoFit/>
+          </a:bodyPr>
+          <a:lstStyle/>
+          <a:p>
+            <a:r>
+              <a:rPr sz="1800" b="1" i="0">
+                <a:solidFill>
+                  <a:srgbClr val="1A1A1A"/>
+                </a:solidFill>
+                <a:latin typeface="Arial"/>
+              </a:rPr>
+              <a:t>A living, governed EA — repository plus practice. The 2–4 permanent architects keep it alive; the EA Board reviews projects against it.</a:t>
+            </a:r>
+          </a:p>
+        </p:txBody>
+      </p:sp>
+      <p:sp>
+        <p:nvSpPr>
+          <p:cNvPr id="13" name="TextBox 12"/>
+          <p:cNvSpPr txBox="1"/>
+          <p:nvPr/>
+        </p:nvSpPr>
+        <p:spPr>
+          <a:xfrm>
+            <a:off x="658368" y="4169664"/>
+            <a:ext cx="2103120" cy="548640"/>
+          </a:xfrm>
+          <a:prstGeom prst="rect">
+            <a:avLst/>
+          </a:prstGeom>
+          <a:noFill/>
+        </p:spPr>
+        <p:txBody>
+          <a:bodyPr wrap="square">
+            <a:spAutoFit/>
+          </a:bodyPr>
+          <a:lstStyle/>
+          <a:p>
+            <a:r>
+              <a:rPr sz="1300" b="1" i="0">
+                <a:solidFill>
+                  <a:srgbClr val="006E96"/>
+                </a:solidFill>
+                <a:latin typeface="Arial"/>
+              </a:rPr>
+              <a:t>CADENCE</a:t>
             </a:r>
           </a:p>
         </p:txBody>
@@ -17716,6 +17614,108 @@
       <p:sp>
         <p:nvSpPr>
           <p:cNvPr id="14" name="TextBox 13"/>
+          <p:cNvSpPr txBox="1"/>
+          <p:nvPr/>
+        </p:nvSpPr>
+        <p:spPr>
+          <a:xfrm>
+            <a:off x="2834640" y="4151376"/>
+            <a:ext cx="8595360" cy="1325880"/>
+          </a:xfrm>
+          <a:prstGeom prst="rect">
+            <a:avLst/>
+          </a:prstGeom>
+          <a:noFill/>
+        </p:spPr>
+        <p:txBody>
+          <a:bodyPr wrap="square">
+            <a:spAutoFit/>
+          </a:bodyPr>
+          <a:lstStyle/>
+          <a:p>
+            <a:r>
+              <a:rPr sz="1800" b="1" i="0">
+                <a:solidFill>
+                  <a:srgbClr val="1A1A1A"/>
+                </a:solidFill>
+                <a:latin typeface="Arial"/>
+              </a:rPr>
+              <a:t>Quarterly Board reviews — indefinitely. New projects reviewed against the architecture; cross-ministry decisions approved; domain boundaries enforced.</a:t>
+            </a:r>
+          </a:p>
+        </p:txBody>
+      </p:sp>
+      <p:sp>
+        <p:nvSpPr>
+          <p:cNvPr id="15" name="TextBox 14"/>
+          <p:cNvSpPr txBox="1"/>
+          <p:nvPr/>
+        </p:nvSpPr>
+        <p:spPr>
+          <a:xfrm>
+            <a:off x="658368" y="5660136"/>
+            <a:ext cx="2103120" cy="548640"/>
+          </a:xfrm>
+          <a:prstGeom prst="rect">
+            <a:avLst/>
+          </a:prstGeom>
+          <a:noFill/>
+        </p:spPr>
+        <p:txBody>
+          <a:bodyPr wrap="square">
+            <a:spAutoFit/>
+          </a:bodyPr>
+          <a:lstStyle/>
+          <a:p>
+            <a:r>
+              <a:rPr sz="1300" b="1" i="0">
+                <a:solidFill>
+                  <a:srgbClr val="006E96"/>
+                </a:solidFill>
+                <a:latin typeface="Arial"/>
+              </a:rPr>
+              <a:t>DURATION</a:t>
+            </a:r>
+          </a:p>
+        </p:txBody>
+      </p:sp>
+      <p:sp>
+        <p:nvSpPr>
+          <p:cNvPr id="16" name="TextBox 15"/>
+          <p:cNvSpPr txBox="1"/>
+          <p:nvPr/>
+        </p:nvSpPr>
+        <p:spPr>
+          <a:xfrm>
+            <a:off x="2834640" y="5641848"/>
+            <a:ext cx="8595360" cy="777240"/>
+          </a:xfrm>
+          <a:prstGeom prst="rect">
+            <a:avLst/>
+          </a:prstGeom>
+          <a:noFill/>
+        </p:spPr>
+        <p:txBody>
+          <a:bodyPr wrap="square">
+            <a:spAutoFit/>
+          </a:bodyPr>
+          <a:lstStyle/>
+          <a:p>
+            <a:r>
+              <a:rPr sz="1800" b="0" i="0">
+                <a:solidFill>
+                  <a:srgbClr val="1A1A1A"/>
+                </a:solidFill>
+                <a:latin typeface="Arial"/>
+              </a:rPr>
+              <a:t>Ongoing — your country’s permanent way of working</a:t>
+            </a:r>
+          </a:p>
+        </p:txBody>
+      </p:sp>
+      <p:sp>
+        <p:nvSpPr>
+          <p:cNvPr id="17" name="TextBox 16"/>
           <p:cNvSpPr txBox="1"/>
           <p:nvPr/>
         </p:nvSpPr>

</xml_diff>